<commit_message>
Add grade distribution plot (IIV, 1000 patients) to slide 6
- Run save_grade_figure4c(): 1000 patients simulated with inter-individual
  variability (IIV on Slope and baseline parameters, De Carlo 2025)
- Results: Neutropenia G1=25.6%, G2=1.2%, G3/G4=0% at AUC=5 Q21Dx2
- Thrombopenia G1=21.5%, G2/G3/G4=0% at AUC=5
- Image inserted in slide 6 (right panel) to show population-level grade
  distribution vs deterministic single-patient Grade 0

https://claude.ai/code/session_01GxFodoNdE8EwfQNaex4rq6
</commit_message>
<xml_diff>
--- a/Avancement_PK_PD_Carboplatine.pptx
+++ b/Avancement_PK_PD_Carboplatine.pptx
@@ -7508,117 +7508,6 @@
       </p:sp>
       <p:sp>
         <p:nvSpPr>
-          <p:cNvPr id="12" name="TextBox 11"/>
-          <p:cNvSpPr txBox="1"/>
-          <p:nvPr/>
-        </p:nvSpPr>
-        <p:spPr>
-          <a:xfrm>
-            <a:off x="6309360" y="1600200"/>
-            <a:ext cx="5394960" cy="3657600"/>
-          </a:xfrm>
-          <a:prstGeom prst="rect">
-            <a:avLst/>
-          </a:prstGeom>
-          <a:noFill/>
-        </p:spPr>
-        <p:txBody>
-          <a:bodyPr wrap="square">
-            <a:spAutoFit/>
-          </a:bodyPr>
-          <a:lstStyle/>
-          <a:p>
-            <a:pPr/>
-            <a:r>
-              <a:rPr sz="1400" b="1">
-                <a:solidFill>
-                  <a:srgbClr val="1A1A1A"/>
-                </a:solidFill>
-              </a:rPr>
-              <a:t>• % patients par grade NCI-CTCAE (Plt &amp; Neut)</a:t>
-            </a:r>
-          </a:p>
-          <a:p>
-            <a:pPr/>
-            <a:r>
-              <a:rPr sz="1400" b="1">
-                <a:solidFill>
-                  <a:srgbClr val="1A1A1A"/>
-                </a:solidFill>
-              </a:rPr>
-              <a:t>• AUC=4 : majorité G0–G1, très peu G3/G4</a:t>
-            </a:r>
-          </a:p>
-          <a:p>
-            <a:pPr/>
-            <a:r>
-              <a:rPr sz="1400" b="1">
-                <a:solidFill>
-                  <a:srgbClr val="1A1A1A"/>
-                </a:solidFill>
-              </a:rPr>
-              <a:t>• AUC=5 : montée des G2–G3</a:t>
-            </a:r>
-          </a:p>
-          <a:p>
-            <a:pPr lvl="1"/>
-            <a:r>
-              <a:rPr sz="1300" b="0">
-                <a:solidFill>
-                  <a:srgbClr val="404040"/>
-                </a:solidFill>
-              </a:rPr>
-              <a:t>  – Plt : ~15% G2, ~5% G3</a:t>
-            </a:r>
-          </a:p>
-          <a:p>
-            <a:pPr/>
-            <a:r>
-              <a:rPr sz="1400" b="1">
-                <a:solidFill>
-                  <a:srgbClr val="1A1A1A"/>
-                </a:solidFill>
-              </a:rPr>
-              <a:t>• AUC=6 : G3/G4 significatifs</a:t>
-            </a:r>
-          </a:p>
-          <a:p>
-            <a:pPr lvl="1"/>
-            <a:r>
-              <a:rPr sz="1300" b="0">
-                <a:solidFill>
-                  <a:srgbClr val="404040"/>
-                </a:solidFill>
-              </a:rPr>
-              <a:t>  – Nécessite ajustement de dose</a:t>
-            </a:r>
-          </a:p>
-          <a:p>
-            <a:pPr/>
-            <a:r>
-              <a:rPr sz="1400" b="1">
-                <a:solidFill>
-                  <a:srgbClr val="1A1A1A"/>
-                </a:solidFill>
-              </a:rPr>
-              <a:t>• Calibration δ_Plt=0.80, γ=0.40</a:t>
-            </a:r>
-          </a:p>
-          <a:p>
-            <a:pPr lvl="1"/>
-            <a:r>
-              <a:rPr sz="1300" b="0">
-                <a:solidFill>
-                  <a:srgbClr val="404040"/>
-                </a:solidFill>
-              </a:rPr>
-              <a:t>  – Reproduit les proportions de Fornari Fig 4c</a:t>
-            </a:r>
-          </a:p>
-        </p:txBody>
-      </p:sp>
-      <p:sp>
-        <p:nvSpPr>
           <p:cNvPr id="13" name="Rectangle 12"/>
           <p:cNvSpPr/>
           <p:nvPr/>
@@ -7807,6 +7696,30 @@
           </a:p>
         </p:txBody>
       </p:sp>
+      <p:pic>
+        <p:nvPicPr>
+          <p:cNvPr id="18" name="Picture 17" descr="Figure4c_grades_AUC5-1.jpg"/>
+          <p:cNvPicPr>
+            <a:picLocks noChangeAspect="1"/>
+          </p:cNvPicPr>
+          <p:nvPr/>
+        </p:nvPicPr>
+        <p:blipFill>
+          <a:blip r:embed="rId2"/>
+          <a:stretch>
+            <a:fillRect/>
+          </a:stretch>
+        </p:blipFill>
+        <p:spPr>
+          <a:xfrm>
+            <a:off x="6309360" y="1600200"/>
+            <a:ext cx="5394960" cy="3700000"/>
+          </a:xfrm>
+          <a:prstGeom prst="rect">
+            <a:avLst/>
+          </a:prstGeom>
+        </p:spPr>
+      </p:pic>
     </p:spTree>
   </p:cSld>
   <p:clrMapOvr>

</xml_diff>